<commit_message>
Fix Network Hardware deck for PowerPoint; add fix_ppr.py to skill
Co-Authored-By: Claude Opus 5.5 <noreply@anthropic.com>
Claude-Session: https://claude.ai/code/session_01J6TacjVoJLZenSaz45LVXj
</commit_message>
<xml_diff>
--- a/9618 P1/Network Hardware/Y12_9618_Lesson_-_Network_Hardware.pptx
+++ b/9618 P1/Network Hardware/Y12_9618_Lesson_-_Network_Hardware.pptx
@@ -3285,9 +3285,6 @@
             <a:pPr algn="ctr" indent="0" marL="0">
               <a:buNone/>
             </a:pPr>
-            <a:pPr algn="ctr" indent="0" marL="0">
-              <a:buNone/>
-            </a:pPr>
             <a:r>
               <a:rPr lang="en-US" sz="800" i="1" dirty="0">
                 <a:solidFill>
@@ -3299,7 +3296,7 @@
               </a:rPr>
               <a:t>Photo: Simon A. Eugster, CC BY-SA 3.0, Wikimedia Commons</a:t>
             </a:r>
-            <a:endParaRPr lang="en-US" sz="1050" dirty="0"/>
+            <a:endParaRPr lang="en-US" sz="800" dirty="0"/>
           </a:p>
         </p:txBody>
       </p:sp>
@@ -3583,9 +3580,6 @@
               </a:rPr>
               <a:t>Ceiling-mounted WAP   </a:t>
             </a:r>
-            <a:pPr algn="ctr" indent="0" marL="0">
-              <a:buNone/>
-            </a:pPr>
             <a:r>
               <a:rPr lang="en-US" sz="800" i="1" dirty="0">
                 <a:solidFill>
@@ -4731,9 +4725,6 @@
               </a:rPr>
               <a:t>Server racks in a data centre   </a:t>
             </a:r>
-            <a:pPr algn="ctr" indent="0" marL="0">
-              <a:buNone/>
-            </a:pPr>
             <a:r>
               <a:rPr lang="en-US" sz="800" i="1" dirty="0">
                 <a:solidFill>
@@ -6084,9 +6075,6 @@
               </a:rPr>
               <a:t>Twisted pair, RJ45 plug   </a:t>
             </a:r>
-            <a:pPr algn="ctr" indent="0" marL="0">
-              <a:buNone/>
-            </a:pPr>
             <a:r>
               <a:rPr lang="en-US" sz="800" i="1" dirty="0">
                 <a:solidFill>
@@ -6193,9 +6181,6 @@
               </a:rPr>
               <a:t>Fibre-optic cables   </a:t>
             </a:r>
-            <a:pPr algn="ctr" indent="0" marL="0">
-              <a:buNone/>
-            </a:pPr>
             <a:r>
               <a:rPr lang="en-US" sz="800" i="1" dirty="0">
                 <a:solidFill>
@@ -7992,9 +7977,6 @@
               </a:rPr>
               <a:t>Wi-Fi repeater in a wall socket   </a:t>
             </a:r>
-            <a:pPr algn="ctr" indent="0" marL="0">
-              <a:buNone/>
-            </a:pPr>
             <a:r>
               <a:rPr lang="en-US" sz="800" i="1" dirty="0">
                 <a:solidFill>
@@ -9948,9 +9930,6 @@
               </a:rPr>
               <a:t>Wireless router   </a:t>
             </a:r>
-            <a:pPr algn="ctr" indent="0" marL="0">
-              <a:buNone/>
-            </a:pPr>
             <a:r>
               <a:rPr lang="en-US" sz="800" i="1" dirty="0">
                 <a:solidFill>
@@ -12952,9 +12931,6 @@
               </a:rPr>
               <a:t>DSL modem   </a:t>
             </a:r>
-            <a:pPr algn="ctr" indent="0" marL="0">
-              <a:buNone/>
-            </a:pPr>
             <a:r>
               <a:rPr lang="en-US" sz="800" i="1" dirty="0">
                 <a:solidFill>
@@ -15681,12 +15657,6 @@
               </a:rPr>
               <a:t>9618/11 Oct/Nov 2023 Q2(a)   </a:t>
             </a:r>
-            <a:pPr indent="0" marL="0">
-              <a:spcAft>
-                <a:spcPts val="600"/>
-              </a:spcAft>
-              <a:buNone/>
-            </a:pPr>
             <a:r>
               <a:rPr lang="en-US" sz="1500" dirty="0">
                 <a:solidFill>
@@ -17662,9 +17632,6 @@
             <a:pPr algn="ctr" indent="0" marL="0">
               <a:buNone/>
             </a:pPr>
-            <a:pPr algn="ctr" indent="0" marL="0">
-              <a:buNone/>
-            </a:pPr>
             <a:r>
               <a:rPr lang="en-US" sz="800" i="1" dirty="0">
                 <a:solidFill>
@@ -17676,7 +17643,7 @@
               </a:rPr>
               <a:t>Photo: David Monniaux, CC BY-SA 3.0, Wikimedia Commons</a:t>
             </a:r>
-            <a:endParaRPr lang="en-US" sz="1050" dirty="0"/>
+            <a:endParaRPr lang="en-US" sz="800" dirty="0"/>
           </a:p>
         </p:txBody>
       </p:sp>
@@ -28708,9 +28675,6 @@
               </a:rPr>
               <a:t>A PCI network card   </a:t>
             </a:r>
-            <a:pPr algn="ctr" indent="0" marL="0">
-              <a:buNone/>
-            </a:pPr>
             <a:r>
               <a:rPr lang="en-US" sz="800" i="1" dirty="0">
                 <a:solidFill>
@@ -29336,9 +29300,6 @@
               </a:rPr>
               <a:t>Internal card   </a:t>
             </a:r>
-            <a:pPr algn="ctr" indent="0" marL="0">
-              <a:buNone/>
-            </a:pPr>
             <a:r>
               <a:rPr lang="en-US" sz="800" i="1" dirty="0">
                 <a:solidFill>
@@ -29445,9 +29406,6 @@
               </a:rPr>
               <a:t>USB adapter   </a:t>
             </a:r>
-            <a:pPr algn="ctr" indent="0" marL="0">
-              <a:buNone/>
-            </a:pPr>
             <a:r>
               <a:rPr lang="en-US" sz="800" i="1" dirty="0">
                 <a:solidFill>
@@ -31897,9 +31855,6 @@
               </a:rPr>
               <a:t>Hub   </a:t>
             </a:r>
-            <a:pPr algn="ctr" indent="0" marL="0">
-              <a:buNone/>
-            </a:pPr>
             <a:r>
               <a:rPr lang="en-US" sz="800" i="1" dirty="0">
                 <a:solidFill>
@@ -32006,9 +31961,6 @@
               </a:rPr>
               <a:t>Switch   </a:t>
             </a:r>
-            <a:pPr algn="ctr" indent="0" marL="0">
-              <a:buNone/>
-            </a:pPr>
             <a:r>
               <a:rPr lang="en-US" sz="800" i="1" dirty="0">
                 <a:solidFill>

</xml_diff>